<commit_message>
feat: new pptx slide
</commit_message>
<xml_diff>
--- a/0-slides/Presentation.pptx
+++ b/0-slides/Presentation.pptx
@@ -10,6 +10,7 @@
     <p:sldId id="258" r:id="rId4"/>
     <p:sldId id="259" r:id="rId5"/>
     <p:sldId id="260" r:id="rId6"/>
+    <p:sldId id="261" r:id="rId7"/>
   </p:sldIdLst>
   <p:sldSz cx="12192000" cy="6858000"/>
   <p:notesSz cx="6858000" cy="9144000"/>
@@ -120,6 +121,7 @@
 <p1510:revInfo xmlns:a="http://schemas.openxmlformats.org/drawingml/2006/main" xmlns:r="http://schemas.openxmlformats.org/officeDocument/2006/relationships" xmlns:p1510="http://schemas.microsoft.com/office/powerpoint/2015/10/main">
   <p1510:revLst>
     <p1510:client id="{01626115-1573-1BB7-A8EB-199D5F273A52}" v="467" dt="2026-10-13T12:55:35.680"/>
+    <p1510:client id="{64AAF726-514A-CCB7-E800-946F51BE5700}" v="353" dt="2026-10-15T09:28:33.880"/>
   </p1510:revLst>
 </p1510:revInfo>
 </file>
@@ -255,7 +257,7 @@
           <a:p>
             <a:fld id="{846CE7D5-CF57-46EF-B807-FDD0502418D4}" type="datetimeFigureOut">
               <a:rPr lang="en-GB" smtClean="0"/>
-              <a:t>13/10/2026</a:t>
+              <a:t>16/10/2026</a:t>
             </a:fld>
             <a:endParaRPr lang="en-GB"/>
           </a:p>
@@ -425,7 +427,7 @@
           <a:p>
             <a:fld id="{846CE7D5-CF57-46EF-B807-FDD0502418D4}" type="datetimeFigureOut">
               <a:rPr lang="en-GB" smtClean="0"/>
-              <a:t>13/10/2026</a:t>
+              <a:t>16/10/2026</a:t>
             </a:fld>
             <a:endParaRPr lang="en-GB"/>
           </a:p>
@@ -605,7 +607,7 @@
           <a:p>
             <a:fld id="{846CE7D5-CF57-46EF-B807-FDD0502418D4}" type="datetimeFigureOut">
               <a:rPr lang="en-GB" smtClean="0"/>
-              <a:t>13/10/2026</a:t>
+              <a:t>16/10/2026</a:t>
             </a:fld>
             <a:endParaRPr lang="en-GB"/>
           </a:p>
@@ -775,7 +777,7 @@
           <a:p>
             <a:fld id="{846CE7D5-CF57-46EF-B807-FDD0502418D4}" type="datetimeFigureOut">
               <a:rPr lang="en-GB" smtClean="0"/>
-              <a:t>13/10/2026</a:t>
+              <a:t>16/10/2026</a:t>
             </a:fld>
             <a:endParaRPr lang="en-GB"/>
           </a:p>
@@ -1021,7 +1023,7 @@
           <a:p>
             <a:fld id="{846CE7D5-CF57-46EF-B807-FDD0502418D4}" type="datetimeFigureOut">
               <a:rPr lang="en-GB" smtClean="0"/>
-              <a:t>13/10/2026</a:t>
+              <a:t>16/10/2026</a:t>
             </a:fld>
             <a:endParaRPr lang="en-GB"/>
           </a:p>
@@ -1253,7 +1255,7 @@
           <a:p>
             <a:fld id="{846CE7D5-CF57-46EF-B807-FDD0502418D4}" type="datetimeFigureOut">
               <a:rPr lang="en-GB" smtClean="0"/>
-              <a:t>13/10/2026</a:t>
+              <a:t>16/10/2026</a:t>
             </a:fld>
             <a:endParaRPr lang="en-GB"/>
           </a:p>
@@ -1620,7 +1622,7 @@
           <a:p>
             <a:fld id="{846CE7D5-CF57-46EF-B807-FDD0502418D4}" type="datetimeFigureOut">
               <a:rPr lang="en-GB" smtClean="0"/>
-              <a:t>13/10/2026</a:t>
+              <a:t>16/10/2026</a:t>
             </a:fld>
             <a:endParaRPr lang="en-GB"/>
           </a:p>
@@ -1738,7 +1740,7 @@
           <a:p>
             <a:fld id="{846CE7D5-CF57-46EF-B807-FDD0502418D4}" type="datetimeFigureOut">
               <a:rPr lang="en-GB" smtClean="0"/>
-              <a:t>13/10/2026</a:t>
+              <a:t>16/10/2026</a:t>
             </a:fld>
             <a:endParaRPr lang="en-GB"/>
           </a:p>
@@ -1833,7 +1835,7 @@
           <a:p>
             <a:fld id="{846CE7D5-CF57-46EF-B807-FDD0502418D4}" type="datetimeFigureOut">
               <a:rPr lang="en-GB" smtClean="0"/>
-              <a:t>13/10/2026</a:t>
+              <a:t>16/10/2026</a:t>
             </a:fld>
             <a:endParaRPr lang="en-GB"/>
           </a:p>
@@ -2110,7 +2112,7 @@
           <a:p>
             <a:fld id="{846CE7D5-CF57-46EF-B807-FDD0502418D4}" type="datetimeFigureOut">
               <a:rPr lang="en-GB" smtClean="0"/>
-              <a:t>13/10/2026</a:t>
+              <a:t>16/10/2026</a:t>
             </a:fld>
             <a:endParaRPr lang="en-GB"/>
           </a:p>
@@ -2363,7 +2365,7 @@
           <a:p>
             <a:fld id="{846CE7D5-CF57-46EF-B807-FDD0502418D4}" type="datetimeFigureOut">
               <a:rPr lang="en-GB" smtClean="0"/>
-              <a:t>13/10/2026</a:t>
+              <a:t>16/10/2026</a:t>
             </a:fld>
             <a:endParaRPr lang="en-GB"/>
           </a:p>
@@ -2576,7 +2578,7 @@
           <a:p>
             <a:fld id="{846CE7D5-CF57-46EF-B807-FDD0502418D4}" type="datetimeFigureOut">
               <a:rPr lang="en-GB" smtClean="0"/>
-              <a:t>13/10/2026</a:t>
+              <a:t>16/10/2026</a:t>
             </a:fld>
             <a:endParaRPr lang="en-GB"/>
           </a:p>
@@ -3118,7 +3120,7 @@
       </p:pic>
       <p:pic>
         <p:nvPicPr>
-          <p:cNvPr id="6" name="Picture 5" descr="A logo of a person in a mask&#10;&#10;AI-generated content may be incorrect.">
+          <p:cNvPr id="6" name="Picture 5" descr="postman logo">
             <a:extLst>
               <a:ext uri="{FF2B5EF4-FFF2-40B4-BE49-F238E27FC236}">
                 <a16:creationId xmlns:a16="http://schemas.microsoft.com/office/drawing/2014/main" id="{20DBA2F2-5C67-4C93-E682-E5D6EB7A50EC}"/>
@@ -3264,8 +3266,8 @@
         </p:nvSpPr>
         <p:spPr>
           <a:xfrm>
-            <a:off x="1748464" y="4004273"/>
-            <a:ext cx="3542610" cy="1938992"/>
+            <a:off x="1547078" y="4004273"/>
+            <a:ext cx="3934495" cy="1938992"/>
           </a:xfrm>
           <a:prstGeom prst="rect">
             <a:avLst/>
@@ -3290,10 +3292,15 @@
                 <a:solidFill>
                   <a:srgbClr val="000000"/>
                 </a:solidFill>
+                <a:latin typeface="Aharoni"/>
+                <a:cs typeface="Aharoni"/>
               </a:rPr>
               <a:t>Open Source</a:t>
             </a:r>
-            <a:endParaRPr lang="en-US"/>
+            <a:endParaRPr lang="en-US" sz="4000">
+              <a:latin typeface="Aharoni"/>
+              <a:cs typeface="Aharoni"/>
+            </a:endParaRPr>
           </a:p>
           <a:p>
             <a:pPr marL="285750" indent="-285750">
@@ -3304,8 +3311,9 @@
               <a:solidFill>
                 <a:srgbClr val="000000"/>
               </a:solidFill>
+              <a:latin typeface="Aharoni"/>
               <a:ea typeface="+mn-lt"/>
-              <a:cs typeface="+mn-lt"/>
+              <a:cs typeface="Aharoni"/>
             </a:endParaRPr>
           </a:p>
           <a:p>
@@ -3318,8 +3326,9 @@
                 <a:solidFill>
                   <a:srgbClr val="000000"/>
                 </a:solidFill>
+                <a:latin typeface="Aharoni"/>
                 <a:ea typeface="+mn-lt"/>
-                <a:cs typeface="+mn-lt"/>
+                <a:cs typeface="Aharoni"/>
               </a:rPr>
               <a:t>100% local</a:t>
             </a:r>
@@ -3327,6 +3336,8 @@
               <a:solidFill>
                 <a:srgbClr val="000000"/>
               </a:solidFill>
+              <a:latin typeface="Aharoni"/>
+              <a:cs typeface="Aharoni"/>
             </a:endParaRPr>
           </a:p>
         </p:txBody>
@@ -3375,8 +3386,8 @@
         </p:nvSpPr>
         <p:spPr>
           <a:xfrm>
-            <a:off x="7010924" y="4003617"/>
-            <a:ext cx="4564517" cy="1938992"/>
+            <a:off x="6940167" y="4003617"/>
+            <a:ext cx="4700589" cy="1938992"/>
           </a:xfrm>
           <a:prstGeom prst="rect">
             <a:avLst/>
@@ -3401,8 +3412,9 @@
                 <a:solidFill>
                   <a:srgbClr val="000000"/>
                 </a:solidFill>
+                <a:latin typeface="Aharoni"/>
                 <a:ea typeface="+mn-lt"/>
-                <a:cs typeface="+mn-lt"/>
+                <a:cs typeface="Aharoni"/>
               </a:rPr>
               <a:t>Git-native</a:t>
             </a:r>
@@ -3410,6 +3422,8 @@
               <a:solidFill>
                 <a:srgbClr val="000000"/>
               </a:solidFill>
+              <a:latin typeface="Aharoni"/>
+              <a:cs typeface="Aharoni"/>
             </a:endParaRPr>
           </a:p>
           <a:p>
@@ -3421,6 +3435,8 @@
               <a:solidFill>
                 <a:srgbClr val="000000"/>
               </a:solidFill>
+              <a:latin typeface="Aharoni"/>
+              <a:cs typeface="Aharoni"/>
             </a:endParaRPr>
           </a:p>
           <a:p>
@@ -3433,6 +3449,8 @@
                 <a:solidFill>
                   <a:srgbClr val="000000"/>
                 </a:solidFill>
+                <a:latin typeface="Aharoni"/>
+                <a:cs typeface="Aharoni"/>
               </a:rPr>
               <a:t>Switching is easy</a:t>
             </a:r>
@@ -3490,7 +3508,7 @@
         <p:spPr>
           <a:xfrm>
             <a:off x="1004185" y="920831"/>
-            <a:ext cx="5184748" cy="5016758"/>
+            <a:ext cx="5184748" cy="5632311"/>
           </a:xfrm>
           <a:prstGeom prst="rect">
             <a:avLst/>
@@ -3511,17 +3529,26 @@
               <a:buChar char="•"/>
             </a:pPr>
             <a:r>
-              <a:rPr lang="en-GB" sz="4000"/>
+              <a:rPr lang="en-GB" sz="4000">
+                <a:latin typeface="Aharoni"/>
+                <a:cs typeface="Aharoni"/>
+              </a:rPr>
               <a:t>Scripting</a:t>
             </a:r>
-            <a:endParaRPr lang="en-US"/>
+            <a:endParaRPr lang="en-US" sz="4000">
+              <a:latin typeface="Aharoni"/>
+              <a:cs typeface="Aharoni"/>
+            </a:endParaRPr>
           </a:p>
           <a:p>
             <a:pPr marL="285750" indent="-285750">
               <a:buFont typeface="Arial"/>
               <a:buChar char="•"/>
             </a:pPr>
-            <a:endParaRPr lang="en-GB" sz="4000" dirty="0"/>
+            <a:endParaRPr lang="en-GB" sz="4000" dirty="0">
+              <a:latin typeface="Aharoni"/>
+              <a:cs typeface="Aharoni"/>
+            </a:endParaRPr>
           </a:p>
           <a:p>
             <a:pPr marL="285750" indent="-285750">
@@ -3529,7 +3556,10 @@
               <a:buChar char="•"/>
             </a:pPr>
             <a:r>
-              <a:rPr lang="en-GB" sz="4000"/>
+              <a:rPr lang="en-GB" sz="4000">
+                <a:latin typeface="Aharoni"/>
+                <a:cs typeface="Aharoni"/>
+              </a:rPr>
               <a:t>Automated Testing</a:t>
             </a:r>
           </a:p>
@@ -3538,7 +3568,10 @@
               <a:buFont typeface="Arial"/>
               <a:buChar char="•"/>
             </a:pPr>
-            <a:endParaRPr lang="en-GB" sz="4000" dirty="0"/>
+            <a:endParaRPr lang="en-GB" sz="4000" dirty="0">
+              <a:latin typeface="Aharoni"/>
+              <a:cs typeface="Aharoni"/>
+            </a:endParaRPr>
           </a:p>
           <a:p>
             <a:pPr marL="285750" indent="-285750">
@@ -3546,7 +3579,10 @@
               <a:buChar char="•"/>
             </a:pPr>
             <a:r>
-              <a:rPr lang="en-GB" sz="4000"/>
+              <a:rPr lang="en-GB" sz="4000">
+                <a:latin typeface="Aharoni"/>
+                <a:cs typeface="Aharoni"/>
+              </a:rPr>
               <a:t>Parent Environments</a:t>
             </a:r>
           </a:p>
@@ -3555,7 +3591,10 @@
               <a:buFont typeface="Arial,Sans-Serif"/>
               <a:buChar char="•"/>
             </a:pPr>
-            <a:endParaRPr lang="en-GB" sz="4000" dirty="0"/>
+            <a:endParaRPr lang="en-GB" sz="4000" dirty="0">
+              <a:latin typeface="Aharoni"/>
+              <a:cs typeface="Aharoni"/>
+            </a:endParaRPr>
           </a:p>
           <a:p>
             <a:pPr marL="285750" indent="-285750">
@@ -3563,7 +3602,10 @@
               <a:buChar char="•"/>
             </a:pPr>
             <a:r>
-              <a:rPr lang="en-GB" sz="4000"/>
+              <a:rPr lang="en-GB" sz="4000">
+                <a:latin typeface="Aharoni"/>
+                <a:cs typeface="Aharoni"/>
+              </a:rPr>
               <a:t>… and more</a:t>
             </a:r>
           </a:p>
@@ -3572,13 +3614,16 @@
               <a:buFont typeface="Arial"/>
               <a:buChar char="•"/>
             </a:pPr>
-            <a:endParaRPr lang="en-GB" sz="4000" dirty="0"/>
+            <a:endParaRPr lang="en-GB" sz="4000" dirty="0">
+              <a:latin typeface="Aharoni"/>
+              <a:cs typeface="Aharoni"/>
+            </a:endParaRPr>
           </a:p>
         </p:txBody>
       </p:sp>
       <p:pic>
         <p:nvPicPr>
-          <p:cNvPr id="5" name="Picture 4" descr="A cartoon of a person holding a mouse&#10;&#10;AI-generated content may be incorrect.">
+          <p:cNvPr id="5" name="Picture 4" descr="Bruno holding Bruno">
             <a:extLst>
               <a:ext uri="{FF2B5EF4-FFF2-40B4-BE49-F238E27FC236}">
                 <a16:creationId xmlns:a16="http://schemas.microsoft.com/office/drawing/2014/main" id="{5D1E8F6E-58F1-D1F6-3806-6A600E17A684}"/>
@@ -3640,6 +3685,365 @@
     <p:extLst>
       <p:ext uri="{BB962C8B-B14F-4D97-AF65-F5344CB8AC3E}">
         <p14:creationId xmlns:p14="http://schemas.microsoft.com/office/powerpoint/2010/main" val="3209295060"/>
+      </p:ext>
+    </p:extLst>
+  </p:cSld>
+  <p:clrMapOvr>
+    <a:masterClrMapping/>
+  </p:clrMapOvr>
+</p:sld>
+</file>
+
+<file path=ppt/slides/slide6.xml><?xml version="1.0" encoding="utf-8"?>
+<p:sld xmlns:a="http://schemas.openxmlformats.org/drawingml/2006/main" xmlns:r="http://schemas.openxmlformats.org/officeDocument/2006/relationships" xmlns:p="http://schemas.openxmlformats.org/presentationml/2006/main">
+  <p:cSld>
+    <p:spTree>
+      <p:nvGrpSpPr>
+        <p:cNvPr id="1" name=""/>
+        <p:cNvGrpSpPr/>
+        <p:nvPr/>
+      </p:nvGrpSpPr>
+      <p:grpSpPr>
+        <a:xfrm>
+          <a:off x="0" y="0"/>
+          <a:ext cx="0" cy="0"/>
+          <a:chOff x="0" y="0"/>
+          <a:chExt cx="0" cy="0"/>
+        </a:xfrm>
+      </p:grpSpPr>
+      <p:sp>
+        <p:nvSpPr>
+          <p:cNvPr id="2" name="TextBox 1">
+            <a:extLst>
+              <a:ext uri="{FF2B5EF4-FFF2-40B4-BE49-F238E27FC236}">
+                <a16:creationId xmlns:a16="http://schemas.microsoft.com/office/drawing/2014/main" id="{7952ED74-0E73-DB84-5977-1D257AE0A44E}"/>
+              </a:ext>
+            </a:extLst>
+          </p:cNvPr>
+          <p:cNvSpPr txBox="1"/>
+          <p:nvPr/>
+        </p:nvSpPr>
+        <p:spPr>
+          <a:xfrm>
+            <a:off x="910603" y="794740"/>
+            <a:ext cx="6890657" cy="5262979"/>
+          </a:xfrm>
+          <a:prstGeom prst="rect">
+            <a:avLst/>
+          </a:prstGeom>
+          <a:noFill/>
+        </p:spPr>
+        <p:txBody>
+          <a:bodyPr rot="0" spcFirstLastPara="0" vertOverflow="overflow" horzOverflow="overflow" vert="horz" wrap="square" lIns="91440" tIns="45720" rIns="91440" bIns="45720" numCol="1" spcCol="0" rtlCol="0" fromWordArt="0" anchor="t" anchorCtr="0" forceAA="0" compatLnSpc="1">
+            <a:prstTxWarp prst="textNoShape">
+              <a:avLst/>
+            </a:prstTxWarp>
+            <a:spAutoFit/>
+          </a:bodyPr>
+          <a:lstStyle/>
+          <a:p>
+            <a:pPr marL="342900" indent="-342900">
+              <a:buFont typeface="Arial"/>
+              <a:buChar char="•"/>
+            </a:pPr>
+            <a:r>
+              <a:rPr lang="en-US" sz="2800" dirty="0" err="1">
+                <a:latin typeface="Aharoni"/>
+                <a:cs typeface="Aharoni"/>
+              </a:rPr>
+              <a:t>GraphQL</a:t>
+            </a:r>
+            <a:r>
+              <a:rPr lang="en-US" sz="2800" dirty="0">
+                <a:latin typeface="Aharoni"/>
+                <a:cs typeface="Aharoni"/>
+              </a:rPr>
+              <a:t>, </a:t>
+            </a:r>
+            <a:r>
+              <a:rPr lang="en-US" sz="2800" dirty="0" err="1">
+                <a:latin typeface="Aharoni"/>
+                <a:cs typeface="Aharoni"/>
+              </a:rPr>
+              <a:t>gRPC</a:t>
+            </a:r>
+            <a:r>
+              <a:rPr lang="en-US" sz="2800" dirty="0">
+                <a:latin typeface="Aharoni"/>
+                <a:cs typeface="Aharoni"/>
+              </a:rPr>
+              <a:t>, WebSocket Support</a:t>
+            </a:r>
+          </a:p>
+          <a:p>
+            <a:pPr marL="342900" indent="-342900">
+              <a:buFont typeface="Arial"/>
+              <a:buChar char="•"/>
+            </a:pPr>
+            <a:r>
+              <a:rPr lang="en-US" sz="2800">
+                <a:latin typeface="Aharoni"/>
+                <a:cs typeface="Aharoni"/>
+              </a:rPr>
+              <a:t>Cookies</a:t>
+            </a:r>
+            <a:endParaRPr lang="en-US" sz="2800" dirty="0">
+              <a:latin typeface="Aharoni"/>
+              <a:cs typeface="Aharoni"/>
+            </a:endParaRPr>
+          </a:p>
+          <a:p>
+            <a:pPr marL="342900" indent="-342900">
+              <a:buFont typeface="Arial"/>
+              <a:buChar char="•"/>
+            </a:pPr>
+            <a:r>
+              <a:rPr lang="en-US" sz="2800">
+                <a:latin typeface="Aharoni"/>
+                <a:cs typeface="Aharoni"/>
+              </a:rPr>
+              <a:t>Proxy</a:t>
+            </a:r>
+            <a:endParaRPr lang="en-US" sz="2800" dirty="0">
+              <a:latin typeface="Aharoni"/>
+              <a:cs typeface="Aharoni"/>
+            </a:endParaRPr>
+          </a:p>
+          <a:p>
+            <a:pPr marL="342900" indent="-342900">
+              <a:buFont typeface="Arial"/>
+              <a:buChar char="•"/>
+            </a:pPr>
+            <a:r>
+              <a:rPr lang="en-US" sz="2800">
+                <a:latin typeface="Aharoni"/>
+                <a:cs typeface="Aharoni"/>
+              </a:rPr>
+              <a:t>Client Certificates</a:t>
+            </a:r>
+            <a:endParaRPr lang="en-US" sz="2800" dirty="0">
+              <a:latin typeface="Aharoni"/>
+              <a:cs typeface="Aharoni"/>
+            </a:endParaRPr>
+          </a:p>
+          <a:p>
+            <a:pPr marL="342900" indent="-342900">
+              <a:buFont typeface="Arial"/>
+              <a:buChar char="•"/>
+            </a:pPr>
+            <a:r>
+              <a:rPr lang="en-US" sz="2800" dirty="0" err="1">
+                <a:latin typeface="Aharoni"/>
+                <a:cs typeface="Aharoni"/>
+              </a:rPr>
+              <a:t>Protobuf</a:t>
+            </a:r>
+            <a:r>
+              <a:rPr lang="en-US" sz="2800" dirty="0">
+                <a:latin typeface="Aharoni"/>
+                <a:cs typeface="Aharoni"/>
+              </a:rPr>
+              <a:t> Files</a:t>
+            </a:r>
+          </a:p>
+          <a:p>
+            <a:pPr marL="342900" indent="-342900">
+              <a:buFont typeface="Arial"/>
+              <a:buChar char="•"/>
+            </a:pPr>
+            <a:r>
+              <a:rPr lang="en-US" sz="2800" dirty="0">
+                <a:latin typeface="Aharoni"/>
+                <a:cs typeface="Aharoni"/>
+              </a:rPr>
+              <a:t>Export as </a:t>
+            </a:r>
+            <a:r>
+              <a:rPr lang="en-US" sz="2800" dirty="0" err="1">
+                <a:latin typeface="Aharoni"/>
+                <a:cs typeface="Aharoni"/>
+              </a:rPr>
+              <a:t>OpenAPI.yml</a:t>
+            </a:r>
+            <a:endParaRPr lang="en-US" sz="2800" dirty="0">
+              <a:latin typeface="Aharoni"/>
+              <a:cs typeface="Aharoni"/>
+            </a:endParaRPr>
+          </a:p>
+          <a:p>
+            <a:pPr marL="342900" indent="-342900">
+              <a:buFont typeface="Arial"/>
+              <a:buChar char="•"/>
+            </a:pPr>
+            <a:r>
+              <a:rPr lang="en-US" sz="2800">
+                <a:latin typeface="Aharoni"/>
+                <a:cs typeface="Aharoni"/>
+              </a:rPr>
+              <a:t>Dir scoped Vars/Tests/Scripts</a:t>
+            </a:r>
+            <a:endParaRPr lang="en-US" sz="2800" dirty="0">
+              <a:latin typeface="Aharoni"/>
+              <a:cs typeface="Aharoni"/>
+            </a:endParaRPr>
+          </a:p>
+          <a:p>
+            <a:pPr marL="342900" indent="-342900">
+              <a:buFont typeface="Arial"/>
+              <a:buChar char="•"/>
+            </a:pPr>
+            <a:r>
+              <a:rPr lang="en-US" sz="2800">
+                <a:latin typeface="Aharoni"/>
+                <a:cs typeface="Aharoni"/>
+              </a:rPr>
+              <a:t>External Secrets Manager</a:t>
+            </a:r>
+            <a:endParaRPr lang="en-US" sz="2800" dirty="0">
+              <a:latin typeface="Aharoni"/>
+              <a:cs typeface="Aharoni"/>
+            </a:endParaRPr>
+          </a:p>
+          <a:p>
+            <a:pPr marL="342900" indent="-342900">
+              <a:buFont typeface="Arial"/>
+              <a:buChar char="•"/>
+            </a:pPr>
+            <a:r>
+              <a:rPr lang="en-US" sz="2800">
+                <a:latin typeface="Aharoni"/>
+                <a:cs typeface="Aharoni"/>
+              </a:rPr>
+              <a:t>Bring</a:t>
+            </a:r>
+            <a:r>
+              <a:rPr lang="en-US" sz="2800" dirty="0">
+                <a:latin typeface="Aharoni"/>
+                <a:cs typeface="Aharoni"/>
+              </a:rPr>
+              <a:t> your own AI key</a:t>
+            </a:r>
+          </a:p>
+          <a:p>
+            <a:pPr marL="342900" indent="-342900">
+              <a:buFont typeface="Arial"/>
+              <a:buChar char="•"/>
+            </a:pPr>
+            <a:r>
+              <a:rPr lang="en-US" sz="2800">
+                <a:latin typeface="Aharoni"/>
+                <a:cs typeface="Aharoni"/>
+              </a:rPr>
+              <a:t>CLI</a:t>
+            </a:r>
+            <a:endParaRPr lang="en-US" sz="2800" dirty="0">
+              <a:latin typeface="Aharoni"/>
+              <a:cs typeface="Aharoni"/>
+            </a:endParaRPr>
+          </a:p>
+          <a:p>
+            <a:pPr marL="342900" indent="-342900">
+              <a:buFont typeface="Arial"/>
+              <a:buChar char="•"/>
+            </a:pPr>
+            <a:r>
+              <a:rPr lang="en-US" sz="2800" dirty="0" err="1">
+                <a:latin typeface="Aharoni"/>
+                <a:cs typeface="Aharoni"/>
+              </a:rPr>
+              <a:t>VSCode</a:t>
+            </a:r>
+            <a:r>
+              <a:rPr lang="en-US" sz="2800" dirty="0">
+                <a:latin typeface="Aharoni"/>
+                <a:cs typeface="Aharoni"/>
+              </a:rPr>
+              <a:t> Plugin</a:t>
+            </a:r>
+          </a:p>
+          <a:p>
+            <a:pPr marL="342900" indent="-342900">
+              <a:buFont typeface="Arial"/>
+              <a:buChar char="•"/>
+            </a:pPr>
+            <a:r>
+              <a:rPr lang="en-US" sz="2800">
+                <a:latin typeface="Aharoni"/>
+                <a:cs typeface="Aharoni"/>
+              </a:rPr>
+              <a:t>...</a:t>
+            </a:r>
+            <a:endParaRPr lang="en-US" sz="2800" dirty="0">
+              <a:latin typeface="Aharoni"/>
+              <a:cs typeface="Aharoni"/>
+            </a:endParaRPr>
+          </a:p>
+        </p:txBody>
+      </p:sp>
+      <p:pic>
+        <p:nvPicPr>
+          <p:cNvPr id="4" name="Picture 3" descr="Bruno holding Bruno">
+            <a:extLst>
+              <a:ext uri="{FF2B5EF4-FFF2-40B4-BE49-F238E27FC236}">
+                <a16:creationId xmlns:a16="http://schemas.microsoft.com/office/drawing/2014/main" id="{DA4CC72E-2447-27B3-18B0-6324E9A1DEA0}"/>
+              </a:ext>
+            </a:extLst>
+          </p:cNvPr>
+          <p:cNvPicPr>
+            <a:picLocks noChangeAspect="1"/>
+          </p:cNvPicPr>
+          <p:nvPr/>
+        </p:nvPicPr>
+        <p:blipFill>
+          <a:blip r:embed="rId2"/>
+          <a:stretch>
+            <a:fillRect/>
+          </a:stretch>
+        </p:blipFill>
+        <p:spPr>
+          <a:xfrm>
+            <a:off x="8271875" y="0"/>
+            <a:ext cx="3918017" cy="6858000"/>
+          </a:xfrm>
+          <a:prstGeom prst="rect">
+            <a:avLst/>
+          </a:prstGeom>
+        </p:spPr>
+      </p:pic>
+      <p:pic>
+        <p:nvPicPr>
+          <p:cNvPr id="6" name="Picture 5" descr="A dog with its tongue out&#10;&#10;AI-generated content may be incorrect.">
+            <a:extLst>
+              <a:ext uri="{FF2B5EF4-FFF2-40B4-BE49-F238E27FC236}">
+                <a16:creationId xmlns:a16="http://schemas.microsoft.com/office/drawing/2014/main" id="{A4E5C95E-A7CB-2A2A-1B34-7EB4C3001A74}"/>
+              </a:ext>
+            </a:extLst>
+          </p:cNvPr>
+          <p:cNvPicPr>
+            <a:picLocks noChangeAspect="1"/>
+          </p:cNvPicPr>
+          <p:nvPr/>
+        </p:nvPicPr>
+        <p:blipFill>
+          <a:blip r:embed="rId3"/>
+          <a:stretch>
+            <a:fillRect/>
+          </a:stretch>
+        </p:blipFill>
+        <p:spPr>
+          <a:xfrm rot="21120000">
+            <a:off x="9342666" y="1954531"/>
+            <a:ext cx="698247" cy="629792"/>
+          </a:xfrm>
+          <a:prstGeom prst="rect">
+            <a:avLst/>
+          </a:prstGeom>
+        </p:spPr>
+      </p:pic>
+    </p:spTree>
+    <p:extLst>
+      <p:ext uri="{BB962C8B-B14F-4D97-AF65-F5344CB8AC3E}">
+        <p14:creationId xmlns:p14="http://schemas.microsoft.com/office/powerpoint/2010/main" val="104774594"/>
       </p:ext>
     </p:extLst>
   </p:cSld>

</xml_diff>